<commit_message>
chore(preview): indice_CAC_40 outputs regeneres
</commit_message>
<xml_diff>
--- a/preview/indice_CAC_40/indice_CAC_40.pptx
+++ b/preview/indice_CAC_40/indice_CAC_40.pptx
@@ -11556,7 +11556,7 @@
                   <a:srgbClr val="555555"/>
                 </a:solidFill>
               </a:rPr>
-              <a:t>EV/EBITDA médian par secteur  ·  Vert = Surpondérer · Amber = Neutre · Rouge = Sous-pondérer</a:t>
+              <a:t>EV/EBITDA median par secteur  ·  Vert = Surponderer · Amber = Neutre · Rouge = Sous-ponderer</a:t>
             </a:r>
           </a:p>
         </p:txBody>
@@ -11735,8 +11735,8 @@
                 </a:solidFill>
               </a:rPr>
               <a:t>Technology traite a 24.8x — prime de 88 % vs la mediane sectorielle (13.2x). Cette prime est justifiee par une croissance BPA structurellement elevee.
-Energy offre la valorisation la plus attractive (6.2x) mais le signal Neutre reflète les risques specifiques au secteur.
-Mediane sectorielle : 13.2x EV/EBITDA — seuil de reference pour evaluer la cherté relative.</a:t>
+Energy offre la valorisation la plus attractive (6.2x) mais le signal Neutre reflete les risques specifiques au secteur.
+Mediane sectorielle : 13.2x EV/EBITDA — seuil de reference pour evaluer la cherte relative.</a:t>
             </a:r>
           </a:p>
         </p:txBody>
@@ -26640,7 +26640,7 @@
                   <a:srgbClr val="555555"/>
                 </a:solidFill>
               </a:rPr>
-              <a:t>L'analyse des indicateurs avancees positionne le cycle en phase d'expansion avancee : ISM Manufacturier autour du seuil 50 (49.8), courbe des taux partiellement normalisee (10Y-2Y +0.2%), Leading...</a:t>
+              <a:t>L'analyse des indicateurs avancees positionne le cycle en phase d'expansion avancee : ISM Manufacturier autour du seuil 50 (49.8), courbe des taux partiellement normalisee (10Y-2Y +0.2%), Leading Indicators OCDE en legere hausse. Cette configuration favorise les secteurs avec forte visibilite BPA et moindre sensibilite aux taux : Technology, Health Care, Financials. Les secteurs defensifs (Consumer Staples,...</a:t>
             </a:r>
           </a:p>
         </p:txBody>

</xml_diff>